<commit_message>
Update Presentación final LdP.pptx
</commit_message>
<xml_diff>
--- a/Evaluación en contacto con el docente/Presentación final LdP.pptx
+++ b/Evaluación en contacto con el docente/Presentación final LdP.pptx
@@ -27781,7 +27781,7 @@
                   <a:schemeClr val="accent2"/>
                 </a:solidFill>
               </a:rPr>
-              <a:t>3 y 4</a:t>
+              <a:t>2, 3 y 4</a:t>
             </a:r>
             <a:r>
               <a:rPr lang="es-ES" noProof="0" dirty="0">
@@ -27843,7 +27843,15 @@
             </a:pPr>
             <a:r>
               <a:rPr lang="es-ES" noProof="0" dirty="0"/>
-              <a:t>El progreso inicial del juego, los diagramas de flujo y el resultado final se encuentran en el siguiente video</a:t>
+              <a:t>El progreso inicial del juego, los diagramas de flujo y el resultado final se encuentran en el siguiente </a:t>
+            </a:r>
+            <a:r>
+              <a:rPr lang="es-ES" noProof="0" dirty="0" err="1"/>
+              <a:t>Github</a:t>
+            </a:r>
+            <a:r>
+              <a:rPr lang="es-ES" noProof="0" dirty="0"/>
+              <a:t>.</a:t>
             </a:r>
           </a:p>
         </p:txBody>
@@ -28502,6 +28510,58 @@
           </p:spPr>
         </p:cxnSp>
       </p:grpSp>
+      <p:sp>
+        <p:nvSpPr>
+          <p:cNvPr id="3" name="CuadroTexto 2">
+            <a:extLst>
+              <a:ext uri="{FF2B5EF4-FFF2-40B4-BE49-F238E27FC236}">
+                <a16:creationId xmlns:a16="http://schemas.microsoft.com/office/drawing/2014/main" id="{6675E835-1C43-37A0-FAD0-2D6FD8F4B48B}"/>
+              </a:ext>
+            </a:extLst>
+          </p:cNvPr>
+          <p:cNvSpPr txBox="1"/>
+          <p:nvPr/>
+        </p:nvSpPr>
+        <p:spPr>
+          <a:xfrm>
+            <a:off x="5293112" y="1483459"/>
+            <a:ext cx="2854712" cy="1200329"/>
+          </a:xfrm>
+          <a:prstGeom prst="rect">
+            <a:avLst/>
+          </a:prstGeom>
+          <a:noFill/>
+        </p:spPr>
+        <p:txBody>
+          <a:bodyPr wrap="square">
+            <a:spAutoFit/>
+          </a:bodyPr>
+          <a:lstStyle/>
+          <a:p>
+            <a:r>
+              <a:rPr lang="es-ES" sz="1800" dirty="0">
+                <a:solidFill>
+                  <a:schemeClr val="accent6"/>
+                </a:solidFill>
+                <a:hlinkClick r:id="rId3"/>
+              </a:rPr>
+              <a:t>https://github.com/EstebanRT-lab/juego-serpiente-AALP-ERT.git</a:t>
+            </a:r>
+            <a:endParaRPr lang="es-ES" sz="1800" dirty="0">
+              <a:solidFill>
+                <a:schemeClr val="accent6"/>
+              </a:solidFill>
+            </a:endParaRPr>
+          </a:p>
+          <a:p>
+            <a:endParaRPr lang="es-ES" sz="1800" dirty="0">
+              <a:solidFill>
+                <a:schemeClr val="accent6"/>
+              </a:solidFill>
+            </a:endParaRPr>
+          </a:p>
+        </p:txBody>
+      </p:sp>
     </p:spTree>
   </p:cSld>
   <p:clrMapOvr>

</xml_diff>